<commit_message>
Add dashboard script to generate a blog status overview in HTML format
</commit_message>
<xml_diff>
--- a/docs/reference/blog-mechanism-slides/export/ブログのしくみ解説スライド.pptx
+++ b/docs/reference/blog-mechanism-slides/export/ブログのしくみ解説スライド.pptx
@@ -1580,7 +1580,7 @@
           <a:p>
             <a:r>
               <a:rPr lang="en-US" dirty="0"/>
-              <a:t>記事ができるまでは6ステップです。1つ目のネタ出しは、AIが切り口をいくつも出してくれます。2つ目が大事で、私が自分の体験を話します。3つ目でAIが下書きを作り、4つ目で別のAIがルールブックに照らして点検し、5つ目で図解を作ります。そして6つ目、pushして公開するのは人です。黄色い2つが人の仕事です。</a:t>
+              <a:t>記事ができるまでは6ステップです。1つ目のネタ出しは、AIが切り口をいくつも出してくれます。2つ目が大事で、私が自分の体験を話します。3つ目でAIが下書きを作り、4つ目で別のAI、校閲担当のアカネがルールブックに照らして点検し、5つ目で図解を作ります。そして6つ目、pushして公開するのは人です。黄色い2つが人の仕事です。</a:t>
             </a:r>
             <a:endParaRPr lang="en-US" dirty="0"/>
           </a:p>
@@ -12108,7 +12108,7 @@
                 <a:ea typeface="BIZ UDPGothic" pitchFamily="34" charset="-122"/>
                 <a:cs typeface="BIZ UDPGothic" pitchFamily="34" charset="-120"/>
               </a:rPr>
-              <a:t>書き上がった下書きを、ルールブックに照らして点検</a:t>
+              <a:t>🖍️ アカネ。書き上がった下書きを、ルールブックに照らして点検</a:t>
             </a:r>
             <a:endParaRPr lang="en-US" sz="1300" dirty="0"/>
           </a:p>
@@ -13679,7 +13679,7 @@
         <p:spPr>
           <a:xfrm>
             <a:off x="1293813" y="3106241"/>
-            <a:ext cx="1239540" cy="289520"/>
+            <a:ext cx="863600" cy="289520"/>
           </a:xfrm>
           <a:prstGeom prst="rect">
             <a:avLst/>
@@ -13723,7 +13723,7 @@
         <p:spPr>
           <a:xfrm>
             <a:off x="1293813" y="3395762"/>
-            <a:ext cx="1239540" cy="223441"/>
+            <a:ext cx="863600" cy="223441"/>
           </a:xfrm>
           <a:prstGeom prst="rect">
             <a:avLst/>
@@ -13752,7 +13752,7 @@
                 <a:ea typeface="Source Code Pro" pitchFamily="34" charset="-122"/>
                 <a:cs typeface="Source Code Pro" pitchFamily="34" charset="-120"/>
               </a:rPr>
-              <a:t>post-reviewer</a:t>
+              <a:t>🖍️ アカネ</a:t>
             </a:r>
             <a:endParaRPr lang="en-US" sz="1200" dirty="0"/>
           </a:p>
@@ -17961,11 +17961,35 @@
             <a:off x="812800" y="1827510"/>
             <a:ext cx="5969000" cy="453926"/>
           </a:xfrm>
-          <a:prstGeom prst="roundRect">
-            <a:avLst>
-              <a:gd name="adj" fmla="val 27978"/>
-            </a:avLst>
-          </a:prstGeom>
+          <a:custGeom>
+            <a:avLst/>
+            <a:gdLst/>
+            <a:ahLst/>
+            <a:cxnLst/>
+            <a:rect l="l" t="t" r="r" b="b"/>
+            <a:pathLst>
+              <a:path w="5969000" h="453926">
+                <a:moveTo>
+                  <a:pt x="127000" y="0"/>
+                </a:moveTo>
+                <a:lnTo>
+                  <a:pt x="5842000" y="0"/>
+                </a:lnTo>
+                <a:arcTo hR="127000" wR="127000" stAng="16200000" swAng="5400000"/>
+                <a:lnTo>
+                  <a:pt x="5969000" y="453926"/>
+                </a:lnTo>
+                <a:lnTo>
+                  <a:pt x="0" y="453926"/>
+                </a:lnTo>
+                <a:lnTo>
+                  <a:pt x="0" y="127000"/>
+                </a:lnTo>
+                <a:arcTo hR="127000" wR="127000" stAng="10800000" swAng="5400000"/>
+                <a:close/>
+              </a:path>
+            </a:pathLst>
+          </a:custGeom>
           <a:solidFill>
             <a:srgbClr val="2F62E6"/>
           </a:solidFill>
@@ -18027,11 +18051,35 @@
             <a:off x="812800" y="2281436"/>
             <a:ext cx="5969000" cy="3560564"/>
           </a:xfrm>
-          <a:prstGeom prst="roundRect">
-            <a:avLst>
-              <a:gd name="adj" fmla="val 3567"/>
-            </a:avLst>
-          </a:prstGeom>
+          <a:custGeom>
+            <a:avLst/>
+            <a:gdLst/>
+            <a:ahLst/>
+            <a:cxnLst/>
+            <a:rect l="l" t="t" r="r" b="b"/>
+            <a:pathLst>
+              <a:path w="5969000" h="3560564">
+                <a:moveTo>
+                  <a:pt x="0" y="0"/>
+                </a:moveTo>
+                <a:lnTo>
+                  <a:pt x="5969000" y="0"/>
+                </a:lnTo>
+                <a:lnTo>
+                  <a:pt x="5969000" y="3433564"/>
+                </a:lnTo>
+                <a:arcTo hR="127000" wR="127000" stAng="0" swAng="5400000"/>
+                <a:lnTo>
+                  <a:pt x="127000" y="3560564"/>
+                </a:lnTo>
+                <a:arcTo hR="127000" wR="127000" stAng="5400000" swAng="5400000"/>
+                <a:lnTo>
+                  <a:pt x="0" y="0"/>
+                </a:lnTo>
+                <a:close/>
+              </a:path>
+            </a:pathLst>
+          </a:custGeom>
           <a:solidFill>
             <a:srgbClr val="0F1B33"/>
           </a:solidFill>

</xml_diff>